<commit_message>
update setup and related files
</commit_message>
<xml_diff>
--- a/RforSASUsers_d1_01.pptx
+++ b/RforSASUsers_d1_01.pptx
@@ -7038,7 +7038,7 @@
             <a:pPr lvl="1"/>
             <a:r>
               <a:rPr lang="en-US" dirty="0"/>
-              <a:t>  1:00 – 3:00 pm</a:t>
+              <a:t>   1:00 – 3:00 pm</a:t>
             </a:r>
           </a:p>
           <a:p>
@@ -7067,8 +7067,12 @@
           <a:p>
             <a:pPr lvl="1"/>
             <a:r>
+              <a:rPr lang="en-US"/>
+              <a:t>   1:00 </a:t>
+            </a:r>
+            <a:r>
               <a:rPr lang="en-US" dirty="0"/>
-              <a:t>  1:00 - 3:00 pm</a:t>
+              <a:t>- 3:00 pm</a:t>
             </a:r>
           </a:p>
           <a:p>
@@ -11157,16 +11161,15 @@
           <a:p>
             <a:pPr lvl="1"/>
             <a:r>
-              <a:rPr lang="en-US">
+              <a:rPr lang="en-US" dirty="0">
                 <a:hlinkClick r:id="rId2"/>
               </a:rPr>
-              <a:t>https://drive.google.com/drive/folders/17oCzxX6KnqswFcrtzXuaUh8iAJh7tttx?usp=sharing</a:t>
-            </a:r>
-            <a:r>
-              <a:rPr lang="en-US"/>
+              <a:t>https://drive.google.com/drive/folders/1Nnb9pA7g7iRLg9o2yidV2MWMWoDTOcHV?usp=sharing</a:t>
+            </a:r>
+            <a:r>
+              <a:rPr lang="en-US" dirty="0"/>
               <a:t> </a:t>
             </a:r>
-            <a:endParaRPr lang="en-US" dirty="0"/>
           </a:p>
           <a:p>
             <a:r>
@@ -11180,7 +11183,7 @@
               <a:rPr lang="en-US" dirty="0">
                 <a:hlinkClick r:id="rId3"/>
               </a:rPr>
-              <a:t>https://tinyurl.com/r4sas-sept2026</a:t>
+              <a:t>https://tinyurl.com/r4sasusers-oct2026</a:t>
             </a:r>
             <a:r>
               <a:rPr lang="en-US" dirty="0"/>
@@ -11190,7 +11193,7 @@
           <a:p>
             <a:r>
               <a:rPr lang="en-US" dirty="0"/>
-              <a:t>H.E.L.P. Dataset and “SAS and R” Book</a:t>
+              <a:t>SLACK:</a:t>
             </a:r>
           </a:p>
           <a:p>
@@ -11199,7 +11202,7 @@
               <a:rPr lang="en-US" dirty="0">
                 <a:hlinkClick r:id="rId4"/>
               </a:rPr>
-              <a:t>https://nhorton.people.amherst.edu/sasr2/datasets.php</a:t>
+              <a:t>https://r-for-sas-users-sh.slack.com</a:t>
             </a:r>
             <a:r>
               <a:rPr lang="en-US" dirty="0"/>
@@ -11207,10 +11210,29 @@
             </a:r>
           </a:p>
           <a:p>
+            <a:r>
+              <a:rPr lang="en-US" dirty="0"/>
+              <a:t>H.E.L.P. Dataset and “SAS and R” Book</a:t>
+            </a:r>
+          </a:p>
+          <a:p>
             <a:pPr lvl="1"/>
             <a:r>
               <a:rPr lang="en-US" dirty="0">
                 <a:hlinkClick r:id="rId5"/>
+              </a:rPr>
+              <a:t>https://nhorton.people.amherst.edu/sasr2/datasets.php</a:t>
+            </a:r>
+            <a:r>
+              <a:rPr lang="en-US" dirty="0"/>
+              <a:t> </a:t>
+            </a:r>
+          </a:p>
+          <a:p>
+            <a:pPr lvl="1"/>
+            <a:r>
+              <a:rPr lang="en-US" dirty="0">
+                <a:hlinkClick r:id="rId6"/>
               </a:rPr>
               <a:t>https://nhorton.people.amherst.edu/sasr2/</a:t>
             </a:r>

</xml_diff>